<commit_message>
docs(deck): 10-slide pitch deck, 3-minute storyboard, thumbnails and generator
Co-Authored-By: Claude Fable 5.1 <noreply@anthropic.com>
</commit_message>
<xml_diff>
--- a/deck/Parallax.pptx
+++ b/deck/Parallax.pptx
@@ -1817,8 +1817,8 @@
         </p:nvSpPr>
         <p:spPr>
           <a:xfrm>
-            <a:off x="566928" y="2011680"/>
-            <a:ext cx="4114800" cy="384048"/>
+            <a:off x="566928" y="1975104"/>
+            <a:ext cx="4114800" cy="685800"/>
           </a:xfrm>
           <a:prstGeom prst="rect">
             <a:avLst/>
@@ -1842,10 +1842,27 @@
                 <a:ea typeface="Helvetica" pitchFamily="34" charset="-122"/>
                 <a:cs typeface="Helvetica" pitchFamily="34" charset="-120"/>
               </a:rPr>
-              <a:t>Many agents. Many branches. One answer.</a:t>
+              <a:t>Many agents. Many branches.</a:t>
             </a:r>
             <a:endParaRPr lang="en-US" sz="2000" dirty="0"/>
           </a:p>
+          <a:p>
+            <a:pPr indent="0" marL="0">
+              <a:buNone/>
+            </a:pPr>
+            <a:r>
+              <a:rPr lang="en-US" sz="2000" b="1" dirty="0">
+                <a:solidFill>
+                  <a:srgbClr val="E6E9F2"/>
+                </a:solidFill>
+                <a:latin typeface="Helvetica" pitchFamily="34" charset="0"/>
+                <a:ea typeface="Helvetica" pitchFamily="34" charset="-122"/>
+                <a:cs typeface="Helvetica" pitchFamily="34" charset="-120"/>
+              </a:rPr>
+              <a:t>One answer.</a:t>
+            </a:r>
+            <a:endParaRPr lang="en-US" sz="2000" dirty="0"/>
+          </a:p>
         </p:txBody>
       </p:sp>
       <p:sp>
@@ -1856,7 +1873,7 @@
         </p:nvSpPr>
         <p:spPr>
           <a:xfrm>
-            <a:off x="566928" y="2450592"/>
+            <a:off x="566928" y="2724912"/>
             <a:ext cx="4114800" cy="502920"/>
           </a:xfrm>
           <a:prstGeom prst="rect">
@@ -1903,7 +1920,7 @@
         </p:blipFill>
         <p:spPr>
           <a:xfrm>
-            <a:off x="566928" y="3035808"/>
+            <a:off x="566928" y="3273552"/>
             <a:ext cx="3291840" cy="234334"/>
           </a:xfrm>
           <a:prstGeom prst="rect">
@@ -1919,7 +1936,7 @@
         </p:nvSpPr>
         <p:spPr>
           <a:xfrm>
-            <a:off x="566928" y="3611880"/>
+            <a:off x="566928" y="3657600"/>
             <a:ext cx="4114800" cy="274320"/>
           </a:xfrm>
           <a:prstGeom prst="rect">
@@ -1958,7 +1975,7 @@
         </p:nvSpPr>
         <p:spPr>
           <a:xfrm>
-            <a:off x="566928" y="3877056"/>
+            <a:off x="566928" y="3913632"/>
             <a:ext cx="4114800" cy="237744"/>
           </a:xfrm>
           <a:prstGeom prst="rect">
@@ -1997,7 +2014,7 @@
         </p:nvSpPr>
         <p:spPr>
           <a:xfrm>
-            <a:off x="566928" y="4114800"/>
+            <a:off x="566928" y="4142232"/>
             <a:ext cx="4206240" cy="237744"/>
           </a:xfrm>
           <a:prstGeom prst="rect">
@@ -2667,8 +2684,8 @@
         </p:nvSpPr>
         <p:spPr>
           <a:xfrm>
-            <a:off x="2651760" y="3346704"/>
-            <a:ext cx="2743200" cy="502920"/>
+            <a:off x="457200" y="3968496"/>
+            <a:ext cx="4846320" cy="274320"/>
           </a:xfrm>
           <a:prstGeom prst="rect">
             <a:avLst/>
@@ -2706,7 +2723,7 @@
         </p:nvSpPr>
         <p:spPr>
           <a:xfrm>
-            <a:off x="457200" y="4114800"/>
+            <a:off x="457200" y="4279392"/>
             <a:ext cx="4846320" cy="274320"/>
           </a:xfrm>
           <a:prstGeom prst="rect">
@@ -3393,7 +3410,7 @@
                 <a:ea typeface="Helvetica" pitchFamily="34" charset="-122"/>
                 <a:cs typeface="Helvetica" pitchFamily="34" charset="-120"/>
               </a:rPr>
-              <a:t>…really eight questions.</a:t>
+              <a:t>→ eight questions</a:t>
             </a:r>
             <a:endParaRPr lang="en-US" sz="1150" dirty="0"/>
           </a:p>
@@ -3407,7 +3424,7 @@
         </p:nvSpPr>
         <p:spPr>
           <a:xfrm>
-            <a:off x="457200" y="2651760"/>
+            <a:off x="457200" y="2743200"/>
             <a:ext cx="786384" cy="786384"/>
           </a:xfrm>
           <a:prstGeom prst="roundRect">
@@ -3442,7 +3459,7 @@
         </p:blipFill>
         <p:spPr>
           <a:xfrm>
-            <a:off x="731520" y="2779776"/>
+            <a:off x="731520" y="2871216"/>
             <a:ext cx="237744" cy="237744"/>
           </a:xfrm>
           <a:prstGeom prst="rect">
@@ -3458,7 +3475,7 @@
         </p:nvSpPr>
         <p:spPr>
           <a:xfrm>
-            <a:off x="457200" y="3090672"/>
+            <a:off x="457200" y="3182112"/>
             <a:ext cx="786384" cy="274320"/>
           </a:xfrm>
           <a:prstGeom prst="rect">
@@ -3497,7 +3514,7 @@
         </p:nvSpPr>
         <p:spPr>
           <a:xfrm>
-            <a:off x="1289304" y="3044952"/>
+            <a:off x="1289304" y="3136392"/>
             <a:ext cx="182880" cy="0"/>
           </a:xfrm>
           <a:prstGeom prst="line">
@@ -3521,7 +3538,7 @@
         </p:nvSpPr>
         <p:spPr>
           <a:xfrm>
-            <a:off x="1517904" y="2651760"/>
+            <a:off x="1517904" y="2743200"/>
             <a:ext cx="786384" cy="786384"/>
           </a:xfrm>
           <a:prstGeom prst="roundRect">
@@ -3556,7 +3573,7 @@
         </p:blipFill>
         <p:spPr>
           <a:xfrm>
-            <a:off x="1792224" y="2779776"/>
+            <a:off x="1792224" y="2871216"/>
             <a:ext cx="237744" cy="237744"/>
           </a:xfrm>
           <a:prstGeom prst="rect">
@@ -3572,7 +3589,7 @@
         </p:nvSpPr>
         <p:spPr>
           <a:xfrm>
-            <a:off x="1517904" y="3090672"/>
+            <a:off x="1517904" y="3182112"/>
             <a:ext cx="786384" cy="274320"/>
           </a:xfrm>
           <a:prstGeom prst="rect">
@@ -3611,7 +3628,7 @@
         </p:nvSpPr>
         <p:spPr>
           <a:xfrm>
-            <a:off x="2350008" y="3044952"/>
+            <a:off x="2350008" y="3136392"/>
             <a:ext cx="182880" cy="0"/>
           </a:xfrm>
           <a:prstGeom prst="line">
@@ -3635,7 +3652,7 @@
         </p:nvSpPr>
         <p:spPr>
           <a:xfrm>
-            <a:off x="2578608" y="2651760"/>
+            <a:off x="2578608" y="2743200"/>
             <a:ext cx="786384" cy="786384"/>
           </a:xfrm>
           <a:prstGeom prst="roundRect">
@@ -3670,7 +3687,7 @@
         </p:blipFill>
         <p:spPr>
           <a:xfrm>
-            <a:off x="2852928" y="2779776"/>
+            <a:off x="2852928" y="2871216"/>
             <a:ext cx="237744" cy="237744"/>
           </a:xfrm>
           <a:prstGeom prst="rect">
@@ -3686,7 +3703,7 @@
         </p:nvSpPr>
         <p:spPr>
           <a:xfrm>
-            <a:off x="2578608" y="3090672"/>
+            <a:off x="2578608" y="3182112"/>
             <a:ext cx="786384" cy="274320"/>
           </a:xfrm>
           <a:prstGeom prst="rect">
@@ -3725,7 +3742,7 @@
         </p:nvSpPr>
         <p:spPr>
           <a:xfrm>
-            <a:off x="3410712" y="3044952"/>
+            <a:off x="3410712" y="3136392"/>
             <a:ext cx="182880" cy="0"/>
           </a:xfrm>
           <a:prstGeom prst="line">
@@ -3749,7 +3766,7 @@
         </p:nvSpPr>
         <p:spPr>
           <a:xfrm>
-            <a:off x="3639312" y="2651760"/>
+            <a:off x="3639312" y="2743200"/>
             <a:ext cx="786384" cy="786384"/>
           </a:xfrm>
           <a:prstGeom prst="roundRect">
@@ -3784,7 +3801,7 @@
         </p:blipFill>
         <p:spPr>
           <a:xfrm>
-            <a:off x="3913632" y="2779776"/>
+            <a:off x="3913632" y="2871216"/>
             <a:ext cx="237744" cy="237744"/>
           </a:xfrm>
           <a:prstGeom prst="rect">
@@ -3800,7 +3817,7 @@
         </p:nvSpPr>
         <p:spPr>
           <a:xfrm>
-            <a:off x="3639312" y="3090672"/>
+            <a:off x="3639312" y="3182112"/>
             <a:ext cx="786384" cy="274320"/>
           </a:xfrm>
           <a:prstGeom prst="rect">
@@ -3839,7 +3856,7 @@
         </p:nvSpPr>
         <p:spPr>
           <a:xfrm>
-            <a:off x="4471416" y="3044952"/>
+            <a:off x="4471416" y="3136392"/>
             <a:ext cx="182880" cy="0"/>
           </a:xfrm>
           <a:prstGeom prst="line">
@@ -3863,7 +3880,7 @@
         </p:nvSpPr>
         <p:spPr>
           <a:xfrm>
-            <a:off x="4700016" y="2651760"/>
+            <a:off x="4700016" y="2743200"/>
             <a:ext cx="786384" cy="786384"/>
           </a:xfrm>
           <a:prstGeom prst="roundRect">
@@ -3898,7 +3915,7 @@
         </p:blipFill>
         <p:spPr>
           <a:xfrm>
-            <a:off x="4974336" y="2779776"/>
+            <a:off x="4974336" y="2871216"/>
             <a:ext cx="237744" cy="237744"/>
           </a:xfrm>
           <a:prstGeom prst="rect">
@@ -3914,7 +3931,7 @@
         </p:nvSpPr>
         <p:spPr>
           <a:xfrm>
-            <a:off x="4700016" y="3090672"/>
+            <a:off x="4700016" y="3182112"/>
             <a:ext cx="786384" cy="274320"/>
           </a:xfrm>
           <a:prstGeom prst="rect">
@@ -3953,7 +3970,7 @@
         </p:nvSpPr>
         <p:spPr>
           <a:xfrm>
-            <a:off x="5532120" y="3044952"/>
+            <a:off x="5532120" y="3136392"/>
             <a:ext cx="182880" cy="0"/>
           </a:xfrm>
           <a:prstGeom prst="line">
@@ -3977,7 +3994,7 @@
         </p:nvSpPr>
         <p:spPr>
           <a:xfrm>
-            <a:off x="5760720" y="2651760"/>
+            <a:off x="5760720" y="2743200"/>
             <a:ext cx="457200" cy="786384"/>
           </a:xfrm>
           <a:prstGeom prst="roundRect">
@@ -4006,7 +4023,7 @@
         </p:nvSpPr>
         <p:spPr>
           <a:xfrm>
-            <a:off x="5760720" y="2651760"/>
+            <a:off x="5760720" y="2743200"/>
             <a:ext cx="457200" cy="786384"/>
           </a:xfrm>
           <a:prstGeom prst="rect">
@@ -4053,7 +4070,7 @@
         </p:blipFill>
         <p:spPr>
           <a:xfrm>
-            <a:off x="457200" y="3767328"/>
+            <a:off x="457200" y="4114800"/>
             <a:ext cx="274320" cy="274320"/>
           </a:xfrm>
           <a:prstGeom prst="rect">
@@ -4069,7 +4086,7 @@
         </p:nvSpPr>
         <p:spPr>
           <a:xfrm>
-            <a:off x="868680" y="3840480"/>
+            <a:off x="868680" y="4187952"/>
             <a:ext cx="561213" cy="146304"/>
           </a:xfrm>
           <a:prstGeom prst="rect">
@@ -4098,7 +4115,7 @@
         </p:nvSpPr>
         <p:spPr>
           <a:xfrm>
-            <a:off x="1457325" y="3840480"/>
+            <a:off x="1457325" y="4187952"/>
             <a:ext cx="561213" cy="146304"/>
           </a:xfrm>
           <a:prstGeom prst="rect">
@@ -4127,7 +4144,7 @@
         </p:nvSpPr>
         <p:spPr>
           <a:xfrm>
-            <a:off x="2045970" y="3840480"/>
+            <a:off x="2045970" y="4187952"/>
             <a:ext cx="561213" cy="146304"/>
           </a:xfrm>
           <a:prstGeom prst="rect">
@@ -4156,7 +4173,7 @@
         </p:nvSpPr>
         <p:spPr>
           <a:xfrm>
-            <a:off x="2634615" y="3840480"/>
+            <a:off x="2634615" y="4187952"/>
             <a:ext cx="561213" cy="146304"/>
           </a:xfrm>
           <a:prstGeom prst="rect">
@@ -4185,7 +4202,7 @@
         </p:nvSpPr>
         <p:spPr>
           <a:xfrm>
-            <a:off x="3223260" y="3840480"/>
+            <a:off x="3223260" y="4187952"/>
             <a:ext cx="561213" cy="146304"/>
           </a:xfrm>
           <a:prstGeom prst="rect">
@@ -4214,7 +4231,7 @@
         </p:nvSpPr>
         <p:spPr>
           <a:xfrm>
-            <a:off x="3811905" y="3840480"/>
+            <a:off x="3811905" y="4187952"/>
             <a:ext cx="561213" cy="146304"/>
           </a:xfrm>
           <a:prstGeom prst="rect">
@@ -4243,7 +4260,7 @@
         </p:nvSpPr>
         <p:spPr>
           <a:xfrm>
-            <a:off x="4400550" y="3840480"/>
+            <a:off x="4400550" y="4187952"/>
             <a:ext cx="561213" cy="146304"/>
           </a:xfrm>
           <a:prstGeom prst="rect">
@@ -4272,7 +4289,7 @@
         </p:nvSpPr>
         <p:spPr>
           <a:xfrm>
-            <a:off x="4989195" y="3840480"/>
+            <a:off x="4989195" y="4187952"/>
             <a:ext cx="561213" cy="146304"/>
           </a:xfrm>
           <a:prstGeom prst="rect">
@@ -4301,7 +4318,7 @@
         </p:nvSpPr>
         <p:spPr>
           <a:xfrm>
-            <a:off x="5623560" y="3767328"/>
+            <a:off x="5623560" y="4114800"/>
             <a:ext cx="640080" cy="274320"/>
           </a:xfrm>
           <a:prstGeom prst="rect">
@@ -5865,7 +5882,7 @@
                 <a:ea typeface="Helvetica" pitchFamily="34" charset="-122"/>
                 <a:cs typeface="Helvetica" pitchFamily="34" charset="-120"/>
               </a:rPr>
-              <a:t>one root DB, one fork per hypothesis</a:t>
+              <a:t>one root, one fork per hypothesis</a:t>
             </a:r>
             <a:endParaRPr lang="en-US" sz="1050" dirty="0"/>
           </a:p>
@@ -6740,7 +6757,7 @@
       </p:sp>
       <p:pic>
         <p:nvPicPr>
-          <p:cNvPr id="6" name="Image 0" descr="/Users/moorthy/Downloads/Projects/Data&amp;AI Hackathon/parallax/docs/assets/screenshots/mission-control-fake-run.png">    </p:cNvPr>
+          <p:cNvPr id="6" name="Image 0" descr="/Users/moorthy/Downloads/Projects/Data&amp;AI Hackathon/parallax/docs/assets/screenshots/mission-control-saas.png">    </p:cNvPr>
           <p:cNvPicPr>
             <a:picLocks noChangeAspect="1"/>
           </p:cNvPicPr>
@@ -7770,7 +7787,7 @@
                 <a:ea typeface="Helvetica" pitchFamily="34" charset="-122"/>
                 <a:cs typeface="Helvetica" pitchFamily="34" charset="-120"/>
               </a:rPr>
-              <a:t>zero-key run, 4 agents</a:t>
+              <a:t>local run: 5 agents, Ollama</a:t>
             </a:r>
             <a:endParaRPr lang="en-US" sz="900" dirty="0"/>
           </a:p>
@@ -8108,7 +8125,7 @@
                 <a:ea typeface="Helvetica" pitchFamily="34" charset="-122"/>
                 <a:cs typeface="Helvetica" pitchFamily="34" charset="-120"/>
               </a:rPr>
-              <a:t>Next.js ⇄ FastAPI over SSE</a:t>
+              <a:t>SSE-driven UI</a:t>
             </a:r>
             <a:endParaRPr lang="en-US" sz="1200" dirty="0"/>
           </a:p>
@@ -8147,7 +8164,7 @@
                 <a:ea typeface="Helvetica" pitchFamily="34" charset="-122"/>
                 <a:cs typeface="Helvetica" pitchFamily="34" charset="-120"/>
               </a:rPr>
-              <a:t>replay buffer, then live</a:t>
+              <a:t>Next.js ⇄ FastAPI, replay then live</a:t>
             </a:r>
             <a:endParaRPr lang="en-US" sz="950" dirty="0"/>
           </a:p>
@@ -9746,7 +9763,7 @@
         </p:nvSpPr>
         <p:spPr>
           <a:xfrm>
-            <a:off x="457200" y="4553712"/>
+            <a:off x="457200" y="4480560"/>
             <a:ext cx="4663440" cy="201168"/>
           </a:xfrm>
           <a:prstGeom prst="rect">
@@ -9771,7 +9788,7 @@
                 <a:ea typeface="Menlo" pitchFamily="34" charset="-122"/>
                 <a:cs typeface="Menlo" pitchFamily="34" charset="-120"/>
               </a:rPr>
-              <a:t>POST /databases/{id}/fork · GET /lineage · bm25_search() · vector_search()</a:t>
+              <a:t>fork · lineage · bm25_search() · vector_search()</a:t>
             </a:r>
             <a:endParaRPr lang="en-US" sz="850" dirty="0"/>
           </a:p>
@@ -10164,7 +10181,7 @@
         <p:spPr>
           <a:xfrm>
             <a:off x="5120640" y="4443984"/>
-            <a:ext cx="1805026" cy="237744"/>
+            <a:ext cx="2156155" cy="237744"/>
           </a:xfrm>
           <a:prstGeom prst="roundRect">
             <a:avLst>
@@ -10191,7 +10208,7 @@
         <p:spPr>
           <a:xfrm>
             <a:off x="5230368" y="4443984"/>
-            <a:ext cx="1622146" cy="237744"/>
+            <a:ext cx="1973275" cy="237744"/>
           </a:xfrm>
           <a:prstGeom prst="rect">
             <a:avLst/>
@@ -10663,8 +10680,8 @@
         </p:nvSpPr>
         <p:spPr>
           <a:xfrm>
-            <a:off x="4343400" y="1874520"/>
-            <a:ext cx="1097280" cy="457200"/>
+            <a:off x="4224528" y="1874520"/>
+            <a:ext cx="1216152" cy="457200"/>
           </a:xfrm>
           <a:prstGeom prst="roundRect">
             <a:avLst>
@@ -10690,8 +10707,8 @@
         </p:nvSpPr>
         <p:spPr>
           <a:xfrm>
-            <a:off x="4343400" y="1874520"/>
-            <a:ext cx="1097280" cy="457200"/>
+            <a:off x="4224528" y="1874520"/>
+            <a:ext cx="1216152" cy="457200"/>
           </a:xfrm>
           <a:prstGeom prst="rect">
             <a:avLst/>
@@ -10754,7 +10771,7 @@
         <p:spPr>
           <a:xfrm>
             <a:off x="3977640" y="2103120"/>
-            <a:ext cx="365760" cy="0"/>
+            <a:ext cx="246888" cy="0"/>
           </a:xfrm>
           <a:prstGeom prst="line">
             <a:avLst/>
@@ -11606,7 +11623,7 @@
         <p:spPr>
           <a:xfrm>
             <a:off x="5806440" y="4443984"/>
-            <a:ext cx="2145182" cy="237744"/>
+            <a:ext cx="2562149" cy="237744"/>
           </a:xfrm>
           <a:prstGeom prst="roundRect">
             <a:avLst>
@@ -11633,7 +11650,7 @@
         <p:spPr>
           <a:xfrm>
             <a:off x="5916168" y="4443984"/>
-            <a:ext cx="1962302" cy="237744"/>
+            <a:ext cx="2379269" cy="237744"/>
           </a:xfrm>
           <a:prstGeom prst="rect">
             <a:avLst/>
@@ -12977,13 +12994,13 @@
             <a:r>
               <a:rPr lang="en-US" sz="850" dirty="0">
                 <a:solidFill>
-                  <a:srgbClr val="67E8F9"/>
+                  <a:srgbClr val="5B6478"/>
                 </a:solidFill>
                 <a:latin typeface="Menlo" pitchFamily="34" charset="0"/>
                 <a:ea typeface="Menlo" pitchFamily="34" charset="-122"/>
                 <a:cs typeface="Menlo" pitchFamily="34" charset="-120"/>
               </a:rPr>
-              <a:t>snyk test · snyk code test</a:t>
+              <a:t>.github/workflows/ci.yml</a:t>
             </a:r>
             <a:endParaRPr lang="en-US" sz="850" dirty="0"/>
           </a:p>
@@ -12998,7 +13015,7 @@
         <p:spPr>
           <a:xfrm>
             <a:off x="5577840" y="4443984"/>
-            <a:ext cx="3108960" cy="237744"/>
+            <a:ext cx="2697480" cy="237744"/>
           </a:xfrm>
           <a:prstGeom prst="roundRect">
             <a:avLst>
@@ -13025,7 +13042,7 @@
         <p:spPr>
           <a:xfrm>
             <a:off x="5687568" y="4443984"/>
-            <a:ext cx="2926080" cy="237744"/>
+            <a:ext cx="2514600" cy="237744"/>
           </a:xfrm>
           <a:prstGeom prst="rect">
             <a:avLst/>
@@ -13049,7 +13066,7 @@
                 <a:ea typeface="Menlo" pitchFamily="34" charset="-122"/>
                 <a:cs typeface="Menlo" pitchFamily="34" charset="-120"/>
               </a:rPr>
-              <a:t>memory/cognee_memory.py · .github/workflows/ci.yml</a:t>
+              <a:t>backend/app/memory/cognee_memory.py</a:t>
             </a:r>
             <a:endParaRPr lang="en-US" sz="850" dirty="0"/>
           </a:p>
@@ -13295,7 +13312,7 @@
           <a:ln/>
         </p:spPr>
         <p:txBody>
-          <a:bodyPr wrap="square" lIns="0" tIns="0" rIns="0" bIns="0" rtlCol="0" anchor="ctr"/>
+          <a:bodyPr wrap="none" lIns="0" tIns="0" rIns="0" bIns="0" rtlCol="0" anchor="ctr"/>
           <a:lstStyle/>
           <a:p>
             <a:pPr indent="0" marL="0">
@@ -13310,7 +13327,7 @@
                 <a:ea typeface="Helvetica" pitchFamily="34" charset="-122"/>
                 <a:cs typeface="Helvetica" pitchFamily="34" charset="-120"/>
               </a:rPr>
-              <a:t>15 / 30 ms</a:t>
+              <a:t>15 ms</a:t>
             </a:r>
             <a:endParaRPr lang="en-US" sz="2400" dirty="0"/>
           </a:p>
@@ -13349,7 +13366,7 @@
                 <a:ea typeface="Helvetica" pitchFamily="34" charset="-122"/>
                 <a:cs typeface="Helvetica" pitchFamily="34" charset="-120"/>
               </a:rPr>
-              <a:t>p50 / p95, burst</a:t>
+              <a:t>p50 · burst</a:t>
             </a:r>
             <a:endParaRPr lang="en-US" sz="900" dirty="0"/>
           </a:p>
@@ -13400,24 +13417,24 @@
           <a:ln/>
         </p:spPr>
         <p:txBody>
-          <a:bodyPr wrap="square" lIns="0" tIns="0" rIns="0" bIns="0" rtlCol="0" anchor="ctr"/>
+          <a:bodyPr wrap="none" lIns="0" tIns="0" rIns="0" bIns="0" rtlCol="0" anchor="ctr"/>
           <a:lstStyle/>
           <a:p>
             <a:pPr indent="0" marL="0">
               <a:buNone/>
             </a:pPr>
             <a:r>
-              <a:rPr lang="en-US" sz="3000" b="1" dirty="0">
-                <a:solidFill>
-                  <a:srgbClr val="E6E9F2"/>
+              <a:rPr lang="en-US" sz="2400" b="1" dirty="0">
+                <a:solidFill>
+                  <a:srgbClr val="22D3EE"/>
                 </a:solidFill>
                 <a:latin typeface="Helvetica" pitchFamily="34" charset="0"/>
                 <a:ea typeface="Helvetica" pitchFamily="34" charset="-122"/>
                 <a:cs typeface="Helvetica" pitchFamily="34" charset="-120"/>
               </a:rPr>
-              <a:t>50</a:t>
-            </a:r>
-            <a:endParaRPr lang="en-US" sz="3000" dirty="0"/>
+              <a:t>30 ms</a:t>
+            </a:r>
+            <a:endParaRPr lang="en-US" sz="2400" dirty="0"/>
           </a:p>
         </p:txBody>
       </p:sp>
@@ -13454,7 +13471,7 @@
                 <a:ea typeface="Helvetica" pitchFamily="34" charset="-122"/>
                 <a:cs typeface="Helvetica" pitchFamily="34" charset="-120"/>
               </a:rPr>
-              <a:t>in-flight</a:t>
+              <a:t>p95 · burst</a:t>
             </a:r>
             <a:endParaRPr lang="en-US" sz="900" dirty="0"/>
           </a:p>
@@ -13505,7 +13522,7 @@
           <a:ln/>
         </p:spPr>
         <p:txBody>
-          <a:bodyPr wrap="square" lIns="0" tIns="0" rIns="0" bIns="0" rtlCol="0" anchor="ctr"/>
+          <a:bodyPr wrap="none" lIns="0" tIns="0" rIns="0" bIns="0" rtlCol="0" anchor="ctr"/>
           <a:lstStyle/>
           <a:p>
             <a:pPr indent="0" marL="0">
@@ -13610,7 +13627,7 @@
           <a:ln/>
         </p:spPr>
         <p:txBody>
-          <a:bodyPr wrap="square" lIns="0" tIns="0" rIns="0" bIns="0" rtlCol="0" anchor="ctr"/>
+          <a:bodyPr wrap="none" lIns="0" tIns="0" rIns="0" bIns="0" rtlCol="0" anchor="ctr"/>
           <a:lstStyle/>
           <a:p>
             <a:pPr indent="0" marL="0">
@@ -13715,7 +13732,7 @@
           <a:ln/>
         </p:spPr>
         <p:txBody>
-          <a:bodyPr wrap="square" lIns="0" tIns="0" rIns="0" bIns="0" rtlCol="0" anchor="ctr"/>
+          <a:bodyPr wrap="none" lIns="0" tIns="0" rIns="0" bIns="0" rtlCol="0" anchor="ctr"/>
           <a:lstStyle/>
           <a:p>
             <a:pPr indent="0" marL="0">
@@ -13820,7 +13837,7 @@
           <a:ln/>
         </p:spPr>
         <p:txBody>
-          <a:bodyPr wrap="square" lIns="0" tIns="0" rIns="0" bIns="0" rtlCol="0" anchor="ctr"/>
+          <a:bodyPr wrap="none" lIns="0" tIns="0" rIns="0" bIns="0" rtlCol="0" anchor="ctr"/>
           <a:lstStyle/>
           <a:p>
             <a:pPr indent="0" marL="0">
@@ -14282,7 +14299,7 @@
                 <a:ea typeface="Helvetica" pitchFamily="34" charset="-122"/>
                 <a:cs typeface="Helvetica" pitchFamily="34" charset="-120"/>
               </a:rPr>
-              <a:t>Bulk-create 10k tenant DBs</a:t>
+              <a:t>Bulk 10k tenant DBs</a:t>
             </a:r>
             <a:endParaRPr lang="en-US" sz="1300" dirty="0"/>
           </a:p>
@@ -14374,7 +14391,7 @@
                 <a:ea typeface="Helvetica" pitchFamily="34" charset="-122"/>
                 <a:cs typeface="Helvetica" pitchFamily="34" charset="-120"/>
               </a:rPr>
-              <a:t>One-click RocketRide deploy</a:t>
+              <a:t>One-click deploy</a:t>
             </a:r>
             <a:endParaRPr lang="en-US" sz="1300" dirty="0"/>
           </a:p>

</xml_diff>